<commit_message>
Category- Working with category create form (part - 1)
</commit_message>
<xml_diff>
--- a/.lessons/56 Category, Subcategory and Child Category Setup/2 Category- Working with category create form (part - 1)/1.pptx
+++ b/.lessons/56 Category, Subcategory and Child Category Setup/2 Category- Working with category create form (part - 1)/1.pptx
@@ -6,8 +6,16 @@
   </p:sldMasterIdLst>
   <p:sldIdLst>
     <p:sldId id="413" r:id="rId2"/>
-    <p:sldId id="414" r:id="rId3"/>
-    <p:sldId id="400" r:id="rId4"/>
+    <p:sldId id="415" r:id="rId3"/>
+    <p:sldId id="416" r:id="rId4"/>
+    <p:sldId id="417" r:id="rId5"/>
+    <p:sldId id="418" r:id="rId6"/>
+    <p:sldId id="419" r:id="rId7"/>
+    <p:sldId id="420" r:id="rId8"/>
+    <p:sldId id="414" r:id="rId9"/>
+    <p:sldId id="400" r:id="rId10"/>
+    <p:sldId id="421" r:id="rId11"/>
+    <p:sldId id="422" r:id="rId12"/>
   </p:sldIdLst>
   <p:sldSz cx="12192000" cy="6858000"/>
   <p:notesSz cx="6858000" cy="9144000"/>
@@ -261,7 +269,7 @@
           <a:p>
             <a:fld id="{3E102D2E-813C-461C-9963-687A650C48C0}" type="datetimeFigureOut">
               <a:rPr lang="en-US" smtClean="0"/>
-              <a:t>6/26/2025</a:t>
+              <a:t>8/16/2025</a:t>
             </a:fld>
             <a:endParaRPr lang="en-US"/>
           </a:p>
@@ -459,7 +467,7 @@
           <a:p>
             <a:fld id="{3E102D2E-813C-461C-9963-687A650C48C0}" type="datetimeFigureOut">
               <a:rPr lang="en-US" smtClean="0"/>
-              <a:t>6/26/2025</a:t>
+              <a:t>8/16/2025</a:t>
             </a:fld>
             <a:endParaRPr lang="en-US"/>
           </a:p>
@@ -667,7 +675,7 @@
           <a:p>
             <a:fld id="{3E102D2E-813C-461C-9963-687A650C48C0}" type="datetimeFigureOut">
               <a:rPr lang="en-US" smtClean="0"/>
-              <a:t>6/26/2025</a:t>
+              <a:t>8/16/2025</a:t>
             </a:fld>
             <a:endParaRPr lang="en-US"/>
           </a:p>
@@ -865,7 +873,7 @@
           <a:p>
             <a:fld id="{3E102D2E-813C-461C-9963-687A650C48C0}" type="datetimeFigureOut">
               <a:rPr lang="en-US" smtClean="0"/>
-              <a:t>6/26/2025</a:t>
+              <a:t>8/16/2025</a:t>
             </a:fld>
             <a:endParaRPr lang="en-US"/>
           </a:p>
@@ -1140,7 +1148,7 @@
           <a:p>
             <a:fld id="{3E102D2E-813C-461C-9963-687A650C48C0}" type="datetimeFigureOut">
               <a:rPr lang="en-US" smtClean="0"/>
-              <a:t>6/26/2025</a:t>
+              <a:t>8/16/2025</a:t>
             </a:fld>
             <a:endParaRPr lang="en-US"/>
           </a:p>
@@ -1405,7 +1413,7 @@
           <a:p>
             <a:fld id="{3E102D2E-813C-461C-9963-687A650C48C0}" type="datetimeFigureOut">
               <a:rPr lang="en-US" smtClean="0"/>
-              <a:t>6/26/2025</a:t>
+              <a:t>8/16/2025</a:t>
             </a:fld>
             <a:endParaRPr lang="en-US"/>
           </a:p>
@@ -1817,7 +1825,7 @@
           <a:p>
             <a:fld id="{3E102D2E-813C-461C-9963-687A650C48C0}" type="datetimeFigureOut">
               <a:rPr lang="en-US" smtClean="0"/>
-              <a:t>6/26/2025</a:t>
+              <a:t>8/16/2025</a:t>
             </a:fld>
             <a:endParaRPr lang="en-US"/>
           </a:p>
@@ -1958,7 +1966,7 @@
           <a:p>
             <a:fld id="{3E102D2E-813C-461C-9963-687A650C48C0}" type="datetimeFigureOut">
               <a:rPr lang="en-US" smtClean="0"/>
-              <a:t>6/26/2025</a:t>
+              <a:t>8/16/2025</a:t>
             </a:fld>
             <a:endParaRPr lang="en-US"/>
           </a:p>
@@ -2071,7 +2079,7 @@
           <a:p>
             <a:fld id="{3E102D2E-813C-461C-9963-687A650C48C0}" type="datetimeFigureOut">
               <a:rPr lang="en-US" smtClean="0"/>
-              <a:t>6/26/2025</a:t>
+              <a:t>8/16/2025</a:t>
             </a:fld>
             <a:endParaRPr lang="en-US"/>
           </a:p>
@@ -2382,7 +2390,7 @@
           <a:p>
             <a:fld id="{3E102D2E-813C-461C-9963-687A650C48C0}" type="datetimeFigureOut">
               <a:rPr lang="en-US" smtClean="0"/>
-              <a:t>6/26/2025</a:t>
+              <a:t>8/16/2025</a:t>
             </a:fld>
             <a:endParaRPr lang="en-US"/>
           </a:p>
@@ -2670,7 +2678,7 @@
           <a:p>
             <a:fld id="{3E102D2E-813C-461C-9963-687A650C48C0}" type="datetimeFigureOut">
               <a:rPr lang="en-US" smtClean="0"/>
-              <a:t>6/26/2025</a:t>
+              <a:t>8/16/2025</a:t>
             </a:fld>
             <a:endParaRPr lang="en-US"/>
           </a:p>
@@ -2911,7 +2919,7 @@
           <a:p>
             <a:fld id="{3E102D2E-813C-461C-9963-687A650C48C0}" type="datetimeFigureOut">
               <a:rPr lang="en-US" smtClean="0"/>
-              <a:t>6/26/2025</a:t>
+              <a:t>8/16/2025</a:t>
             </a:fld>
             <a:endParaRPr lang="en-US"/>
           </a:p>
@@ -3369,21 +3377,60 @@
               <a:buNone/>
             </a:pPr>
             <a:r>
-              <a:rPr kumimoji="0" lang="en-US" altLang="en-US" sz="1300" b="0" i="0" u="none" strike="noStrike" cap="none" normalizeH="0" baseline="0">
-                <a:ln>
-                  <a:noFill/>
-                </a:ln>
-                <a:solidFill>
-                  <a:schemeClr val="tx1"/>
-                </a:solidFill>
-                <a:effectLst/>
-                <a:latin typeface="Arial" panose="020B0604020202020204" pitchFamily="34" charset="0"/>
-              </a:rPr>
-              <a:t>.</a:t>
-            </a:r>
-          </a:p>
-        </p:txBody>
-      </p:sp>
+              <a:rPr lang="en-US" altLang="en-US" sz="1300">
+                <a:latin typeface="Arial" panose="020B0604020202020204" pitchFamily="34" charset="0"/>
+              </a:rPr>
+              <a:t>Create s</a:t>
+            </a:r>
+            <a:r>
+              <a:rPr lang="az-Latn-AZ" altLang="en-US" sz="1300">
+                <a:latin typeface="Arial" panose="020B0604020202020204" pitchFamily="34" charset="0"/>
+              </a:rPr>
+              <a:t>əhifəsinə keçmək üçün A elementinə route əlavə edirik və controllerdə yönləndiririk.</a:t>
+            </a:r>
+            <a:endParaRPr kumimoji="0" lang="en-US" altLang="en-US" sz="1300" b="0" i="0" u="none" strike="noStrike" cap="none" normalizeH="0" baseline="0">
+              <a:ln>
+                <a:noFill/>
+              </a:ln>
+              <a:solidFill>
+                <a:schemeClr val="tx1"/>
+              </a:solidFill>
+              <a:effectLst/>
+              <a:latin typeface="Arial" panose="020B0604020202020204" pitchFamily="34" charset="0"/>
+            </a:endParaRPr>
+          </a:p>
+        </p:txBody>
+      </p:sp>
+      <p:pic>
+        <p:nvPicPr>
+          <p:cNvPr id="4" name="Picture 3">
+            <a:extLst>
+              <a:ext uri="{FF2B5EF4-FFF2-40B4-BE49-F238E27FC236}">
+                <a16:creationId xmlns:a16="http://schemas.microsoft.com/office/drawing/2014/main" id="{CD7C5C85-7005-8072-1079-51B4F0ABA85D}"/>
+              </a:ext>
+            </a:extLst>
+          </p:cNvPr>
+          <p:cNvPicPr>
+            <a:picLocks noChangeAspect="1"/>
+          </p:cNvPicPr>
+          <p:nvPr/>
+        </p:nvPicPr>
+        <p:blipFill>
+          <a:blip r:embed="rId2"/>
+          <a:stretch>
+            <a:fillRect/>
+          </a:stretch>
+        </p:blipFill>
+        <p:spPr>
+          <a:xfrm>
+            <a:off x="2327564" y="1188226"/>
+            <a:ext cx="9864436" cy="5669774"/>
+          </a:xfrm>
+          <a:prstGeom prst="rect">
+            <a:avLst/>
+          </a:prstGeom>
+        </p:spPr>
+      </p:pic>
     </p:spTree>
     <p:extLst>
       <p:ext uri="{BB962C8B-B14F-4D97-AF65-F5344CB8AC3E}">
@@ -3397,7 +3444,1389 @@
 </p:sld>
 </file>
 
+<file path=ppt/slides/slide10.xml><?xml version="1.0" encoding="utf-8"?>
+<p:sld xmlns:a="http://schemas.openxmlformats.org/drawingml/2006/main" xmlns:r="http://schemas.openxmlformats.org/officeDocument/2006/relationships" xmlns:p="http://schemas.openxmlformats.org/presentationml/2006/main">
+  <p:cSld>
+    <p:spTree>
+      <p:nvGrpSpPr>
+        <p:cNvPr id="1" name="">
+          <a:extLst>
+            <a:ext uri="{FF2B5EF4-FFF2-40B4-BE49-F238E27FC236}">
+              <a16:creationId xmlns:a16="http://schemas.microsoft.com/office/drawing/2014/main" id="{C9DAF69D-5583-0382-9BEF-94DD4CA27533}"/>
+            </a:ext>
+          </a:extLst>
+        </p:cNvPr>
+        <p:cNvGrpSpPr/>
+        <p:nvPr/>
+      </p:nvGrpSpPr>
+      <p:grpSpPr>
+        <a:xfrm>
+          <a:off x="0" y="0"/>
+          <a:ext cx="0" cy="0"/>
+          <a:chOff x="0" y="0"/>
+          <a:chExt cx="0" cy="0"/>
+        </a:xfrm>
+      </p:grpSpPr>
+      <p:sp>
+        <p:nvSpPr>
+          <p:cNvPr id="3" name="TextBox 2">
+            <a:extLst>
+              <a:ext uri="{FF2B5EF4-FFF2-40B4-BE49-F238E27FC236}">
+                <a16:creationId xmlns:a16="http://schemas.microsoft.com/office/drawing/2014/main" id="{7134524A-3CFF-D0DF-DD1E-B2ADD4A37FA6}"/>
+              </a:ext>
+            </a:extLst>
+          </p:cNvPr>
+          <p:cNvSpPr txBox="1"/>
+          <p:nvPr/>
+        </p:nvSpPr>
+        <p:spPr>
+          <a:xfrm>
+            <a:off x="217714" y="255046"/>
+            <a:ext cx="11756571" cy="355354"/>
+          </a:xfrm>
+          <a:prstGeom prst="rect">
+            <a:avLst/>
+          </a:prstGeom>
+          <a:noFill/>
+        </p:spPr>
+        <p:txBody>
+          <a:bodyPr wrap="square">
+            <a:spAutoFit/>
+          </a:bodyPr>
+          <a:lstStyle/>
+          <a:p>
+            <a:pPr>
+              <a:lnSpc>
+                <a:spcPct val="150000"/>
+              </a:lnSpc>
+              <a:buNone/>
+            </a:pPr>
+            <a:r>
+              <a:rPr kumimoji="0" lang="en-US" altLang="en-US" sz="1300" b="0" i="0" u="none" strike="noStrike" cap="none" normalizeH="0" baseline="0">
+                <a:ln>
+                  <a:noFill/>
+                </a:ln>
+                <a:solidFill>
+                  <a:schemeClr val="tx1"/>
+                </a:solidFill>
+                <a:effectLst/>
+                <a:latin typeface="Arial" panose="020B0604020202020204" pitchFamily="34" charset="0"/>
+              </a:rPr>
+              <a:t>.</a:t>
+            </a:r>
+          </a:p>
+        </p:txBody>
+      </p:sp>
+    </p:spTree>
+    <p:extLst>
+      <p:ext uri="{BB962C8B-B14F-4D97-AF65-F5344CB8AC3E}">
+        <p14:creationId xmlns:p14="http://schemas.microsoft.com/office/powerpoint/2010/main" val="4076116143"/>
+      </p:ext>
+    </p:extLst>
+  </p:cSld>
+  <p:clrMapOvr>
+    <a:masterClrMapping/>
+  </p:clrMapOvr>
+</p:sld>
+</file>
+
+<file path=ppt/slides/slide11.xml><?xml version="1.0" encoding="utf-8"?>
+<p:sld xmlns:a="http://schemas.openxmlformats.org/drawingml/2006/main" xmlns:r="http://schemas.openxmlformats.org/officeDocument/2006/relationships" xmlns:p="http://schemas.openxmlformats.org/presentationml/2006/main">
+  <p:cSld>
+    <p:spTree>
+      <p:nvGrpSpPr>
+        <p:cNvPr id="1" name="">
+          <a:extLst>
+            <a:ext uri="{FF2B5EF4-FFF2-40B4-BE49-F238E27FC236}">
+              <a16:creationId xmlns:a16="http://schemas.microsoft.com/office/drawing/2014/main" id="{E92A5FB4-CBA1-F3D2-E204-04D70C1A90A6}"/>
+            </a:ext>
+          </a:extLst>
+        </p:cNvPr>
+        <p:cNvGrpSpPr/>
+        <p:nvPr/>
+      </p:nvGrpSpPr>
+      <p:grpSpPr>
+        <a:xfrm>
+          <a:off x="0" y="0"/>
+          <a:ext cx="0" cy="0"/>
+          <a:chOff x="0" y="0"/>
+          <a:chExt cx="0" cy="0"/>
+        </a:xfrm>
+      </p:grpSpPr>
+      <p:sp>
+        <p:nvSpPr>
+          <p:cNvPr id="3" name="TextBox 2">
+            <a:extLst>
+              <a:ext uri="{FF2B5EF4-FFF2-40B4-BE49-F238E27FC236}">
+                <a16:creationId xmlns:a16="http://schemas.microsoft.com/office/drawing/2014/main" id="{35AE6BB9-E7A7-C452-95A3-F1784A36FE82}"/>
+              </a:ext>
+            </a:extLst>
+          </p:cNvPr>
+          <p:cNvSpPr txBox="1"/>
+          <p:nvPr/>
+        </p:nvSpPr>
+        <p:spPr>
+          <a:xfrm>
+            <a:off x="217714" y="255046"/>
+            <a:ext cx="11756571" cy="355354"/>
+          </a:xfrm>
+          <a:prstGeom prst="rect">
+            <a:avLst/>
+          </a:prstGeom>
+          <a:noFill/>
+        </p:spPr>
+        <p:txBody>
+          <a:bodyPr wrap="square">
+            <a:spAutoFit/>
+          </a:bodyPr>
+          <a:lstStyle/>
+          <a:p>
+            <a:pPr>
+              <a:lnSpc>
+                <a:spcPct val="150000"/>
+              </a:lnSpc>
+              <a:buNone/>
+            </a:pPr>
+            <a:r>
+              <a:rPr kumimoji="0" lang="en-US" altLang="en-US" sz="1300" b="0" i="0" u="none" strike="noStrike" cap="none" normalizeH="0" baseline="0">
+                <a:ln>
+                  <a:noFill/>
+                </a:ln>
+                <a:solidFill>
+                  <a:schemeClr val="tx1"/>
+                </a:solidFill>
+                <a:effectLst/>
+                <a:latin typeface="Arial" panose="020B0604020202020204" pitchFamily="34" charset="0"/>
+              </a:rPr>
+              <a:t>.</a:t>
+            </a:r>
+          </a:p>
+        </p:txBody>
+      </p:sp>
+    </p:spTree>
+    <p:extLst>
+      <p:ext uri="{BB962C8B-B14F-4D97-AF65-F5344CB8AC3E}">
+        <p14:creationId xmlns:p14="http://schemas.microsoft.com/office/powerpoint/2010/main" val="1514735154"/>
+      </p:ext>
+    </p:extLst>
+  </p:cSld>
+  <p:clrMapOvr>
+    <a:masterClrMapping/>
+  </p:clrMapOvr>
+</p:sld>
+</file>
+
 <file path=ppt/slides/slide2.xml><?xml version="1.0" encoding="utf-8"?>
+<p:sld xmlns:a="http://schemas.openxmlformats.org/drawingml/2006/main" xmlns:r="http://schemas.openxmlformats.org/officeDocument/2006/relationships" xmlns:p="http://schemas.openxmlformats.org/presentationml/2006/main">
+  <p:cSld>
+    <p:spTree>
+      <p:nvGrpSpPr>
+        <p:cNvPr id="1" name="">
+          <a:extLst>
+            <a:ext uri="{FF2B5EF4-FFF2-40B4-BE49-F238E27FC236}">
+              <a16:creationId xmlns:a16="http://schemas.microsoft.com/office/drawing/2014/main" id="{9B46B78F-5399-0318-C2BC-9D4E0569ADB5}"/>
+            </a:ext>
+          </a:extLst>
+        </p:cNvPr>
+        <p:cNvGrpSpPr/>
+        <p:nvPr/>
+      </p:nvGrpSpPr>
+      <p:grpSpPr>
+        <a:xfrm>
+          <a:off x="0" y="0"/>
+          <a:ext cx="0" cy="0"/>
+          <a:chOff x="0" y="0"/>
+          <a:chExt cx="0" cy="0"/>
+        </a:xfrm>
+      </p:grpSpPr>
+      <p:sp>
+        <p:nvSpPr>
+          <p:cNvPr id="3" name="TextBox 2">
+            <a:extLst>
+              <a:ext uri="{FF2B5EF4-FFF2-40B4-BE49-F238E27FC236}">
+                <a16:creationId xmlns:a16="http://schemas.microsoft.com/office/drawing/2014/main" id="{AF0677E5-892D-ADCF-8DF6-0176626F9BCE}"/>
+              </a:ext>
+            </a:extLst>
+          </p:cNvPr>
+          <p:cNvSpPr txBox="1"/>
+          <p:nvPr/>
+        </p:nvSpPr>
+        <p:spPr>
+          <a:xfrm>
+            <a:off x="217714" y="255046"/>
+            <a:ext cx="11756571" cy="355354"/>
+          </a:xfrm>
+          <a:prstGeom prst="rect">
+            <a:avLst/>
+          </a:prstGeom>
+          <a:noFill/>
+        </p:spPr>
+        <p:txBody>
+          <a:bodyPr wrap="square">
+            <a:spAutoFit/>
+          </a:bodyPr>
+          <a:lstStyle/>
+          <a:p>
+            <a:pPr>
+              <a:lnSpc>
+                <a:spcPct val="150000"/>
+              </a:lnSpc>
+              <a:buNone/>
+            </a:pPr>
+            <a:r>
+              <a:rPr lang="en-US" altLang="en-US" sz="1300" b="1">
+                <a:latin typeface="Arial" panose="020B0604020202020204" pitchFamily="34" charset="0"/>
+              </a:rPr>
+              <a:t>resources\views\admin\category\</a:t>
+            </a:r>
+            <a:r>
+              <a:rPr lang="en-US" altLang="en-US" sz="1300" b="1" u="sng">
+                <a:latin typeface="Arial" panose="020B0604020202020204" pitchFamily="34" charset="0"/>
+              </a:rPr>
+              <a:t>index.blade.php</a:t>
+            </a:r>
+            <a:r>
+              <a:rPr lang="az-Latn-AZ" altLang="en-US" sz="1300" b="1">
+                <a:latin typeface="Arial" panose="020B0604020202020204" pitchFamily="34" charset="0"/>
+              </a:rPr>
+              <a:t> </a:t>
+            </a:r>
+            <a:r>
+              <a:rPr lang="az-Latn-AZ" altLang="en-US" sz="1300">
+                <a:latin typeface="Arial" panose="020B0604020202020204" pitchFamily="34" charset="0"/>
+              </a:rPr>
+              <a:t>faylında bu işarətlənən hissəni silməyi unutmuşdum. İndi silək.</a:t>
+            </a:r>
+            <a:endParaRPr kumimoji="0" lang="en-US" altLang="en-US" sz="1300" b="0" i="0" u="none" strike="noStrike" cap="none" normalizeH="0" baseline="0">
+              <a:ln>
+                <a:noFill/>
+              </a:ln>
+              <a:solidFill>
+                <a:schemeClr val="tx1"/>
+              </a:solidFill>
+              <a:effectLst/>
+              <a:latin typeface="Arial" panose="020B0604020202020204" pitchFamily="34" charset="0"/>
+            </a:endParaRPr>
+          </a:p>
+        </p:txBody>
+      </p:sp>
+      <p:pic>
+        <p:nvPicPr>
+          <p:cNvPr id="4" name="Picture 3">
+            <a:extLst>
+              <a:ext uri="{FF2B5EF4-FFF2-40B4-BE49-F238E27FC236}">
+                <a16:creationId xmlns:a16="http://schemas.microsoft.com/office/drawing/2014/main" id="{59EF09D1-4422-97FE-CCEC-BEF3617E39B2}"/>
+              </a:ext>
+            </a:extLst>
+          </p:cNvPr>
+          <p:cNvPicPr>
+            <a:picLocks noChangeAspect="1"/>
+          </p:cNvPicPr>
+          <p:nvPr/>
+        </p:nvPicPr>
+        <p:blipFill>
+          <a:blip r:embed="rId2"/>
+          <a:stretch>
+            <a:fillRect/>
+          </a:stretch>
+        </p:blipFill>
+        <p:spPr>
+          <a:xfrm>
+            <a:off x="5369875" y="1468582"/>
+            <a:ext cx="6822125" cy="5389418"/>
+          </a:xfrm>
+          <a:prstGeom prst="rect">
+            <a:avLst/>
+          </a:prstGeom>
+        </p:spPr>
+      </p:pic>
+    </p:spTree>
+    <p:extLst>
+      <p:ext uri="{BB962C8B-B14F-4D97-AF65-F5344CB8AC3E}">
+        <p14:creationId xmlns:p14="http://schemas.microsoft.com/office/powerpoint/2010/main" val="2248589008"/>
+      </p:ext>
+    </p:extLst>
+  </p:cSld>
+  <p:clrMapOvr>
+    <a:masterClrMapping/>
+  </p:clrMapOvr>
+</p:sld>
+</file>
+
+<file path=ppt/slides/slide3.xml><?xml version="1.0" encoding="utf-8"?>
+<p:sld xmlns:a="http://schemas.openxmlformats.org/drawingml/2006/main" xmlns:r="http://schemas.openxmlformats.org/officeDocument/2006/relationships" xmlns:p="http://schemas.openxmlformats.org/presentationml/2006/main">
+  <p:cSld>
+    <p:spTree>
+      <p:nvGrpSpPr>
+        <p:cNvPr id="1" name="">
+          <a:extLst>
+            <a:ext uri="{FF2B5EF4-FFF2-40B4-BE49-F238E27FC236}">
+              <a16:creationId xmlns:a16="http://schemas.microsoft.com/office/drawing/2014/main" id="{C3F06B79-B7C8-4C45-C8DB-DC8F819B40C8}"/>
+            </a:ext>
+          </a:extLst>
+        </p:cNvPr>
+        <p:cNvGrpSpPr/>
+        <p:nvPr/>
+      </p:nvGrpSpPr>
+      <p:grpSpPr>
+        <a:xfrm>
+          <a:off x="0" y="0"/>
+          <a:ext cx="0" cy="0"/>
+          <a:chOff x="0" y="0"/>
+          <a:chExt cx="0" cy="0"/>
+        </a:xfrm>
+      </p:grpSpPr>
+      <p:sp>
+        <p:nvSpPr>
+          <p:cNvPr id="3" name="TextBox 2">
+            <a:extLst>
+              <a:ext uri="{FF2B5EF4-FFF2-40B4-BE49-F238E27FC236}">
+                <a16:creationId xmlns:a16="http://schemas.microsoft.com/office/drawing/2014/main" id="{766B3893-C7ED-6CC2-FBF4-283792AF4058}"/>
+              </a:ext>
+            </a:extLst>
+          </p:cNvPr>
+          <p:cNvSpPr txBox="1"/>
+          <p:nvPr/>
+        </p:nvSpPr>
+        <p:spPr>
+          <a:xfrm>
+            <a:off x="217714" y="255046"/>
+            <a:ext cx="11756571" cy="655436"/>
+          </a:xfrm>
+          <a:prstGeom prst="rect">
+            <a:avLst/>
+          </a:prstGeom>
+          <a:noFill/>
+        </p:spPr>
+        <p:txBody>
+          <a:bodyPr wrap="square">
+            <a:spAutoFit/>
+          </a:bodyPr>
+          <a:lstStyle/>
+          <a:p>
+            <a:pPr>
+              <a:lnSpc>
+                <a:spcPct val="150000"/>
+              </a:lnSpc>
+              <a:buNone/>
+            </a:pPr>
+            <a:r>
+              <a:rPr lang="en-US" altLang="en-US" sz="1300" b="1">
+                <a:latin typeface="Arial" panose="020B0604020202020204" pitchFamily="34" charset="0"/>
+              </a:rPr>
+              <a:t>resources\views\admin\category\</a:t>
+            </a:r>
+            <a:r>
+              <a:rPr lang="en-US" altLang="en-US" sz="1300" b="1" u="sng">
+                <a:latin typeface="Arial" panose="020B0604020202020204" pitchFamily="34" charset="0"/>
+              </a:rPr>
+              <a:t>index.blade.php</a:t>
+            </a:r>
+            <a:r>
+              <a:rPr lang="az-Latn-AZ" altLang="en-US" sz="1300" b="1">
+                <a:latin typeface="Arial" panose="020B0604020202020204" pitchFamily="34" charset="0"/>
+              </a:rPr>
+              <a:t> </a:t>
+            </a:r>
+            <a:r>
+              <a:rPr lang="az-Latn-AZ" altLang="en-US" sz="1300">
+                <a:latin typeface="Arial" panose="020B0604020202020204" pitchFamily="34" charset="0"/>
+              </a:rPr>
+              <a:t>faylında </a:t>
+            </a:r>
+            <a:r>
+              <a:rPr lang="en-US" altLang="en-US" sz="1300">
+                <a:latin typeface="Arial" panose="020B0604020202020204" pitchFamily="34" charset="0"/>
+              </a:rPr>
+              <a:t>olan </a:t>
+            </a:r>
+            <a:r>
+              <a:rPr lang="az-Latn-AZ" altLang="en-US" sz="1300">
+                <a:latin typeface="Arial" panose="020B0604020202020204" pitchFamily="34" charset="0"/>
+              </a:rPr>
+              <a:t>məlumatları, </a:t>
+            </a:r>
+            <a:r>
+              <a:rPr lang="en-US" altLang="en-US" sz="1300" b="1">
+                <a:latin typeface="Arial" panose="020B0604020202020204" pitchFamily="34" charset="0"/>
+              </a:rPr>
+              <a:t>resources\views\admin\category\</a:t>
+            </a:r>
+            <a:r>
+              <a:rPr lang="en-US" altLang="en-US" sz="1300" b="1" u="sng">
+                <a:latin typeface="Arial" panose="020B0604020202020204" pitchFamily="34" charset="0"/>
+              </a:rPr>
+              <a:t>create.blade.php</a:t>
+            </a:r>
+            <a:r>
+              <a:rPr lang="az-Latn-AZ" altLang="en-US" sz="1300" b="1">
+                <a:latin typeface="Arial" panose="020B0604020202020204" pitchFamily="34" charset="0"/>
+              </a:rPr>
+              <a:t> </a:t>
+            </a:r>
+            <a:r>
+              <a:rPr lang="az-Latn-AZ" altLang="en-US" sz="1300">
+                <a:latin typeface="Arial" panose="020B0604020202020204" pitchFamily="34" charset="0"/>
+              </a:rPr>
+              <a:t>faylına köçürürük və lazım olmayan elementləri silərək </a:t>
+            </a:r>
+            <a:r>
+              <a:rPr lang="az-Latn-AZ" altLang="en-US" sz="1300" b="1">
+                <a:latin typeface="Arial" panose="020B0604020202020204" pitchFamily="34" charset="0"/>
+              </a:rPr>
+              <a:t>form tag </a:t>
+            </a:r>
+            <a:r>
+              <a:rPr lang="az-Latn-AZ" altLang="en-US" sz="1300">
+                <a:latin typeface="Arial" panose="020B0604020202020204" pitchFamily="34" charset="0"/>
+              </a:rPr>
+              <a:t>-inə lazım olan </a:t>
+            </a:r>
+            <a:r>
+              <a:rPr lang="az-Latn-AZ" altLang="en-US" sz="1300" b="1">
+                <a:latin typeface="Arial" panose="020B0604020202020204" pitchFamily="34" charset="0"/>
+              </a:rPr>
+              <a:t>elementləri</a:t>
+            </a:r>
+            <a:r>
+              <a:rPr lang="az-Latn-AZ" altLang="en-US" sz="1300">
+                <a:latin typeface="Arial" panose="020B0604020202020204" pitchFamily="34" charset="0"/>
+              </a:rPr>
+              <a:t> əlavə edirik. </a:t>
+            </a:r>
+            <a:endParaRPr lang="en-US" altLang="en-US" sz="1300">
+              <a:latin typeface="Arial" panose="020B0604020202020204" pitchFamily="34" charset="0"/>
+            </a:endParaRPr>
+          </a:p>
+        </p:txBody>
+      </p:sp>
+      <p:pic>
+        <p:nvPicPr>
+          <p:cNvPr id="4" name="Picture 3">
+            <a:extLst>
+              <a:ext uri="{FF2B5EF4-FFF2-40B4-BE49-F238E27FC236}">
+                <a16:creationId xmlns:a16="http://schemas.microsoft.com/office/drawing/2014/main" id="{157B2457-83B3-F28F-556D-5A1B17391592}"/>
+              </a:ext>
+            </a:extLst>
+          </p:cNvPr>
+          <p:cNvPicPr>
+            <a:picLocks noChangeAspect="1"/>
+          </p:cNvPicPr>
+          <p:nvPr/>
+        </p:nvPicPr>
+        <p:blipFill>
+          <a:blip r:embed="rId2"/>
+          <a:stretch>
+            <a:fillRect/>
+          </a:stretch>
+        </p:blipFill>
+        <p:spPr>
+          <a:xfrm>
+            <a:off x="1955461" y="1376218"/>
+            <a:ext cx="10236538" cy="5481782"/>
+          </a:xfrm>
+          <a:prstGeom prst="rect">
+            <a:avLst/>
+          </a:prstGeom>
+        </p:spPr>
+      </p:pic>
+    </p:spTree>
+    <p:extLst>
+      <p:ext uri="{BB962C8B-B14F-4D97-AF65-F5344CB8AC3E}">
+        <p14:creationId xmlns:p14="http://schemas.microsoft.com/office/powerpoint/2010/main" val="1520337171"/>
+      </p:ext>
+    </p:extLst>
+  </p:cSld>
+  <p:clrMapOvr>
+    <a:masterClrMapping/>
+  </p:clrMapOvr>
+</p:sld>
+</file>
+
+<file path=ppt/slides/slide4.xml><?xml version="1.0" encoding="utf-8"?>
+<p:sld xmlns:a="http://schemas.openxmlformats.org/drawingml/2006/main" xmlns:r="http://schemas.openxmlformats.org/officeDocument/2006/relationships" xmlns:p="http://schemas.openxmlformats.org/presentationml/2006/main">
+  <p:cSld>
+    <p:spTree>
+      <p:nvGrpSpPr>
+        <p:cNvPr id="1" name="">
+          <a:extLst>
+            <a:ext uri="{FF2B5EF4-FFF2-40B4-BE49-F238E27FC236}">
+              <a16:creationId xmlns:a16="http://schemas.microsoft.com/office/drawing/2014/main" id="{59A1B343-5C53-AD3A-B9DF-A1175745518F}"/>
+            </a:ext>
+          </a:extLst>
+        </p:cNvPr>
+        <p:cNvGrpSpPr/>
+        <p:nvPr/>
+      </p:nvGrpSpPr>
+      <p:grpSpPr>
+        <a:xfrm>
+          <a:off x="0" y="0"/>
+          <a:ext cx="0" cy="0"/>
+          <a:chOff x="0" y="0"/>
+          <a:chExt cx="0" cy="0"/>
+        </a:xfrm>
+      </p:grpSpPr>
+      <p:sp>
+        <p:nvSpPr>
+          <p:cNvPr id="3" name="TextBox 2">
+            <a:extLst>
+              <a:ext uri="{FF2B5EF4-FFF2-40B4-BE49-F238E27FC236}">
+                <a16:creationId xmlns:a16="http://schemas.microsoft.com/office/drawing/2014/main" id="{05872888-B5F0-5107-5816-B383070449B1}"/>
+              </a:ext>
+            </a:extLst>
+          </p:cNvPr>
+          <p:cNvSpPr txBox="1"/>
+          <p:nvPr/>
+        </p:nvSpPr>
+        <p:spPr>
+          <a:xfrm>
+            <a:off x="217715" y="255046"/>
+            <a:ext cx="5425704" cy="3656257"/>
+          </a:xfrm>
+          <a:prstGeom prst="rect">
+            <a:avLst/>
+          </a:prstGeom>
+          <a:noFill/>
+        </p:spPr>
+        <p:txBody>
+          <a:bodyPr wrap="square">
+            <a:spAutoFit/>
+          </a:bodyPr>
+          <a:lstStyle/>
+          <a:p>
+            <a:pPr>
+              <a:lnSpc>
+                <a:spcPct val="150000"/>
+              </a:lnSpc>
+              <a:buNone/>
+            </a:pPr>
+            <a:r>
+              <a:rPr lang="az-Latn-AZ" altLang="en-US" sz="1300">
+                <a:latin typeface="Arial" panose="020B0604020202020204" pitchFamily="34" charset="0"/>
+              </a:rPr>
+              <a:t>Əlavə etdiyimiz elementlər qırmızı ilə işarətlənənlərdir.</a:t>
+            </a:r>
+          </a:p>
+          <a:p>
+            <a:pPr>
+              <a:lnSpc>
+                <a:spcPct val="150000"/>
+              </a:lnSpc>
+              <a:buNone/>
+            </a:pPr>
+            <a:endParaRPr kumimoji="0" lang="az-Latn-AZ" altLang="en-US" sz="1300" b="0" i="0" u="none" strike="noStrike" cap="none" normalizeH="0" baseline="0">
+              <a:ln>
+                <a:noFill/>
+              </a:ln>
+              <a:solidFill>
+                <a:schemeClr val="tx1"/>
+              </a:solidFill>
+              <a:effectLst/>
+              <a:latin typeface="Arial" panose="020B0604020202020204" pitchFamily="34" charset="0"/>
+            </a:endParaRPr>
+          </a:p>
+          <a:p>
+            <a:pPr>
+              <a:lnSpc>
+                <a:spcPct val="150000"/>
+              </a:lnSpc>
+              <a:buNone/>
+            </a:pPr>
+            <a:r>
+              <a:rPr kumimoji="0" lang="az-Latn-AZ" altLang="en-US" sz="1300" b="0" i="0" u="none" strike="noStrike" cap="none" normalizeH="0" baseline="0">
+                <a:ln>
+                  <a:noFill/>
+                </a:ln>
+                <a:solidFill>
+                  <a:schemeClr val="tx1"/>
+                </a:solidFill>
+                <a:effectLst/>
+                <a:latin typeface="Arial" panose="020B0604020202020204" pitchFamily="34" charset="0"/>
+              </a:rPr>
+              <a:t>Tez olması üçün bu elementləri </a:t>
+            </a:r>
+            <a:r>
+              <a:rPr lang="en-US" altLang="en-US" sz="1300" b="1">
+                <a:latin typeface="Arial" panose="020B0604020202020204" pitchFamily="34" charset="0"/>
+              </a:rPr>
+              <a:t>resources\views\admin\</a:t>
+            </a:r>
+            <a:r>
+              <a:rPr lang="en-US" altLang="en-US" sz="1300" b="1" u="sng">
+                <a:latin typeface="Arial" panose="020B0604020202020204" pitchFamily="34" charset="0"/>
+              </a:rPr>
+              <a:t>slider\create.blade.php</a:t>
+            </a:r>
+            <a:r>
+              <a:rPr lang="az-Latn-AZ" altLang="en-US" sz="1300">
+                <a:latin typeface="Arial" panose="020B0604020202020204" pitchFamily="34" charset="0"/>
+              </a:rPr>
+              <a:t> faylından götürə bilərsiz.</a:t>
+            </a:r>
+          </a:p>
+          <a:p>
+            <a:pPr>
+              <a:lnSpc>
+                <a:spcPct val="150000"/>
+              </a:lnSpc>
+              <a:buNone/>
+            </a:pPr>
+            <a:endParaRPr kumimoji="0" lang="az-Latn-AZ" altLang="en-US" sz="1300" b="0" i="0" u="none" strike="noStrike" cap="none" normalizeH="0" baseline="0">
+              <a:ln>
+                <a:noFill/>
+              </a:ln>
+              <a:solidFill>
+                <a:schemeClr val="tx1"/>
+              </a:solidFill>
+              <a:effectLst/>
+              <a:latin typeface="Arial" panose="020B0604020202020204" pitchFamily="34" charset="0"/>
+            </a:endParaRPr>
+          </a:p>
+          <a:p>
+            <a:pPr>
+              <a:lnSpc>
+                <a:spcPct val="150000"/>
+              </a:lnSpc>
+              <a:buNone/>
+            </a:pPr>
+            <a:endParaRPr lang="az-Latn-AZ" altLang="en-US" sz="1300">
+              <a:latin typeface="Arial" panose="020B0604020202020204" pitchFamily="34" charset="0"/>
+            </a:endParaRPr>
+          </a:p>
+          <a:p>
+            <a:pPr>
+              <a:lnSpc>
+                <a:spcPct val="150000"/>
+              </a:lnSpc>
+              <a:buNone/>
+            </a:pPr>
+            <a:r>
+              <a:rPr kumimoji="0" lang="az-Latn-AZ" altLang="en-US" sz="1300" b="0" i="0" u="none" strike="noStrike" cap="none" normalizeH="0" baseline="0">
+                <a:ln>
+                  <a:noFill/>
+                </a:ln>
+                <a:solidFill>
+                  <a:schemeClr val="tx1"/>
+                </a:solidFill>
+                <a:effectLst/>
+                <a:latin typeface="Arial" panose="020B0604020202020204" pitchFamily="34" charset="0"/>
+              </a:rPr>
+              <a:t>Burada </a:t>
+            </a:r>
+            <a:r>
+              <a:rPr lang="az-Latn-AZ" altLang="en-US" sz="1300" b="1">
+                <a:latin typeface="Arial" panose="020B0604020202020204" pitchFamily="34" charset="0"/>
+              </a:rPr>
+              <a:t>1ci input</a:t>
+            </a:r>
+            <a:r>
+              <a:rPr lang="az-Latn-AZ" altLang="en-US" sz="1300">
+                <a:latin typeface="Arial" panose="020B0604020202020204" pitchFamily="34" charset="0"/>
+              </a:rPr>
+              <a:t> taginin </a:t>
+            </a:r>
+            <a:r>
+              <a:rPr lang="az-Latn-AZ" altLang="en-US" sz="1300" b="1">
+                <a:latin typeface="Arial" panose="020B0604020202020204" pitchFamily="34" charset="0"/>
+              </a:rPr>
+              <a:t>type</a:t>
+            </a:r>
+            <a:r>
+              <a:rPr lang="az-Latn-AZ" altLang="en-US" sz="1300">
+                <a:latin typeface="Arial" panose="020B0604020202020204" pitchFamily="34" charset="0"/>
+              </a:rPr>
+              <a:t> atributu </a:t>
+            </a:r>
+            <a:r>
+              <a:rPr lang="az-Latn-AZ" altLang="en-US" sz="1300" b="1">
+                <a:latin typeface="Arial" panose="020B0604020202020204" pitchFamily="34" charset="0"/>
+              </a:rPr>
+              <a:t>text</a:t>
+            </a:r>
+            <a:r>
+              <a:rPr lang="az-Latn-AZ" altLang="en-US" sz="1300">
+                <a:latin typeface="Arial" panose="020B0604020202020204" pitchFamily="34" charset="0"/>
+              </a:rPr>
+              <a:t> dəyərindədir. Bura bootstrap-in icon üçün istifadə edilən class adlarını qoya bilərik. </a:t>
+            </a:r>
+          </a:p>
+          <a:p>
+            <a:pPr>
+              <a:lnSpc>
+                <a:spcPct val="150000"/>
+              </a:lnSpc>
+              <a:buNone/>
+            </a:pPr>
+            <a:endParaRPr kumimoji="0" lang="az-Latn-AZ" altLang="en-US" sz="1300" b="0" i="0" u="none" strike="noStrike" cap="none" normalizeH="0" baseline="0">
+              <a:ln>
+                <a:noFill/>
+              </a:ln>
+              <a:solidFill>
+                <a:schemeClr val="tx1"/>
+              </a:solidFill>
+              <a:effectLst/>
+              <a:latin typeface="Arial" panose="020B0604020202020204" pitchFamily="34" charset="0"/>
+            </a:endParaRPr>
+          </a:p>
+          <a:p>
+            <a:pPr>
+              <a:lnSpc>
+                <a:spcPct val="150000"/>
+              </a:lnSpc>
+              <a:buNone/>
+            </a:pPr>
+            <a:r>
+              <a:rPr lang="az-Latn-AZ" altLang="en-US" sz="1300">
+                <a:latin typeface="Arial" panose="020B0604020202020204" pitchFamily="34" charset="0"/>
+              </a:rPr>
+              <a:t>Həmin bootstrap üçün `</a:t>
+            </a:r>
+            <a:r>
+              <a:rPr lang="az-Latn-AZ" altLang="en-US" sz="1300" b="1">
+                <a:solidFill>
+                  <a:srgbClr val="0070C0"/>
+                </a:solidFill>
+                <a:latin typeface="Arial" panose="020B0604020202020204" pitchFamily="34" charset="0"/>
+              </a:rPr>
+              <a:t>https://victor-valencia.github.io/bootstrap-iconpicker/</a:t>
+            </a:r>
+            <a:r>
+              <a:rPr lang="az-Latn-AZ" altLang="en-US" sz="1300">
+                <a:latin typeface="Arial" panose="020B0604020202020204" pitchFamily="34" charset="0"/>
+              </a:rPr>
+              <a:t>` bu saytdan </a:t>
+            </a:r>
+            <a:r>
+              <a:rPr lang="az-Latn-AZ" altLang="en-US" sz="1300" b="1">
+                <a:latin typeface="Arial" panose="020B0604020202020204" pitchFamily="34" charset="0"/>
+              </a:rPr>
+              <a:t>bootsrap js və css icon </a:t>
+            </a:r>
+            <a:r>
+              <a:rPr lang="az-Latn-AZ" altLang="en-US" sz="1300">
+                <a:latin typeface="Arial" panose="020B0604020202020204" pitchFamily="34" charset="0"/>
+              </a:rPr>
+              <a:t>fayllarını endiririk.</a:t>
+            </a:r>
+            <a:endParaRPr kumimoji="0" lang="en-US" altLang="en-US" sz="1300" b="0" i="0" u="none" strike="noStrike" cap="none" normalizeH="0" baseline="0">
+              <a:ln>
+                <a:noFill/>
+              </a:ln>
+              <a:solidFill>
+                <a:schemeClr val="tx1"/>
+              </a:solidFill>
+              <a:effectLst/>
+              <a:latin typeface="Arial" panose="020B0604020202020204" pitchFamily="34" charset="0"/>
+            </a:endParaRPr>
+          </a:p>
+        </p:txBody>
+      </p:sp>
+      <p:pic>
+        <p:nvPicPr>
+          <p:cNvPr id="4" name="Picture 3">
+            <a:extLst>
+              <a:ext uri="{FF2B5EF4-FFF2-40B4-BE49-F238E27FC236}">
+                <a16:creationId xmlns:a16="http://schemas.microsoft.com/office/drawing/2014/main" id="{7A8E2E60-7E5B-4BFA-1DDA-C57471BA956E}"/>
+              </a:ext>
+            </a:extLst>
+          </p:cNvPr>
+          <p:cNvPicPr>
+            <a:picLocks noChangeAspect="1"/>
+          </p:cNvPicPr>
+          <p:nvPr/>
+        </p:nvPicPr>
+        <p:blipFill>
+          <a:blip r:embed="rId2"/>
+          <a:stretch>
+            <a:fillRect/>
+          </a:stretch>
+        </p:blipFill>
+        <p:spPr>
+          <a:xfrm>
+            <a:off x="5740297" y="0"/>
+            <a:ext cx="6451703" cy="6858000"/>
+          </a:xfrm>
+          <a:prstGeom prst="rect">
+            <a:avLst/>
+          </a:prstGeom>
+        </p:spPr>
+      </p:pic>
+      <p:pic>
+        <p:nvPicPr>
+          <p:cNvPr id="6" name="Picture 5">
+            <a:extLst>
+              <a:ext uri="{FF2B5EF4-FFF2-40B4-BE49-F238E27FC236}">
+                <a16:creationId xmlns:a16="http://schemas.microsoft.com/office/drawing/2014/main" id="{B8BFCF37-E2E0-678B-35ED-0A4B7D68CB24}"/>
+              </a:ext>
+            </a:extLst>
+          </p:cNvPr>
+          <p:cNvPicPr>
+            <a:picLocks noChangeAspect="1"/>
+          </p:cNvPicPr>
+          <p:nvPr/>
+        </p:nvPicPr>
+        <p:blipFill>
+          <a:blip r:embed="rId3"/>
+          <a:stretch>
+            <a:fillRect/>
+          </a:stretch>
+        </p:blipFill>
+        <p:spPr>
+          <a:xfrm>
+            <a:off x="0" y="4950209"/>
+            <a:ext cx="4492087" cy="1907791"/>
+          </a:xfrm>
+          <a:prstGeom prst="rect">
+            <a:avLst/>
+          </a:prstGeom>
+          <a:ln w="38100" cap="sq">
+            <a:solidFill>
+              <a:srgbClr val="000000"/>
+            </a:solidFill>
+            <a:prstDash val="solid"/>
+            <a:miter lim="800000"/>
+          </a:ln>
+          <a:effectLst>
+            <a:outerShdw blurRad="50800" dist="38100" dir="2700000" algn="tl" rotWithShape="0">
+              <a:srgbClr val="000000">
+                <a:alpha val="43000"/>
+              </a:srgbClr>
+            </a:outerShdw>
+          </a:effectLst>
+        </p:spPr>
+      </p:pic>
+    </p:spTree>
+    <p:extLst>
+      <p:ext uri="{BB962C8B-B14F-4D97-AF65-F5344CB8AC3E}">
+        <p14:creationId xmlns:p14="http://schemas.microsoft.com/office/powerpoint/2010/main" val="3261440187"/>
+      </p:ext>
+    </p:extLst>
+  </p:cSld>
+  <p:clrMapOvr>
+    <a:masterClrMapping/>
+  </p:clrMapOvr>
+</p:sld>
+</file>
+
+<file path=ppt/slides/slide5.xml><?xml version="1.0" encoding="utf-8"?>
+<p:sld xmlns:a="http://schemas.openxmlformats.org/drawingml/2006/main" xmlns:r="http://schemas.openxmlformats.org/officeDocument/2006/relationships" xmlns:p="http://schemas.openxmlformats.org/presentationml/2006/main">
+  <p:cSld>
+    <p:spTree>
+      <p:nvGrpSpPr>
+        <p:cNvPr id="1" name="">
+          <a:extLst>
+            <a:ext uri="{FF2B5EF4-FFF2-40B4-BE49-F238E27FC236}">
+              <a16:creationId xmlns:a16="http://schemas.microsoft.com/office/drawing/2014/main" id="{F09050CB-694A-DA75-E84F-07C9A89978B5}"/>
+            </a:ext>
+          </a:extLst>
+        </p:cNvPr>
+        <p:cNvGrpSpPr/>
+        <p:nvPr/>
+      </p:nvGrpSpPr>
+      <p:grpSpPr>
+        <a:xfrm>
+          <a:off x="0" y="0"/>
+          <a:ext cx="0" cy="0"/>
+          <a:chOff x="0" y="0"/>
+          <a:chExt cx="0" cy="0"/>
+        </a:xfrm>
+      </p:grpSpPr>
+      <p:sp>
+        <p:nvSpPr>
+          <p:cNvPr id="3" name="TextBox 2">
+            <a:extLst>
+              <a:ext uri="{FF2B5EF4-FFF2-40B4-BE49-F238E27FC236}">
+                <a16:creationId xmlns:a16="http://schemas.microsoft.com/office/drawing/2014/main" id="{BC9AD785-A17D-7141-0558-22EC485FB773}"/>
+              </a:ext>
+            </a:extLst>
+          </p:cNvPr>
+          <p:cNvSpPr txBox="1"/>
+          <p:nvPr/>
+        </p:nvSpPr>
+        <p:spPr>
+          <a:xfrm>
+            <a:off x="217713" y="116501"/>
+            <a:ext cx="11756571" cy="355354"/>
+          </a:xfrm>
+          <a:prstGeom prst="rect">
+            <a:avLst/>
+          </a:prstGeom>
+          <a:noFill/>
+        </p:spPr>
+        <p:txBody>
+          <a:bodyPr wrap="square">
+            <a:spAutoFit/>
+          </a:bodyPr>
+          <a:lstStyle/>
+          <a:p>
+            <a:pPr>
+              <a:lnSpc>
+                <a:spcPct val="150000"/>
+              </a:lnSpc>
+              <a:buNone/>
+            </a:pPr>
+            <a:r>
+              <a:rPr lang="az-Latn-AZ" altLang="en-US" sz="1300" b="1">
+                <a:latin typeface="Arial" panose="020B0604020202020204" pitchFamily="34" charset="0"/>
+              </a:rPr>
+              <a:t>RAR</a:t>
+            </a:r>
+            <a:r>
+              <a:rPr lang="az-Latn-AZ" altLang="en-US" sz="1300">
+                <a:latin typeface="Arial" panose="020B0604020202020204" pitchFamily="34" charset="0"/>
+              </a:rPr>
+              <a:t> içindən, </a:t>
+            </a:r>
+            <a:r>
+              <a:rPr lang="az-Latn-AZ" altLang="en-US" sz="1300" b="1">
+                <a:latin typeface="Arial" panose="020B0604020202020204" pitchFamily="34" charset="0"/>
+              </a:rPr>
+              <a:t>JS</a:t>
+            </a:r>
+            <a:r>
+              <a:rPr lang="az-Latn-AZ" altLang="en-US" sz="1300">
+                <a:latin typeface="Arial" panose="020B0604020202020204" pitchFamily="34" charset="0"/>
+              </a:rPr>
+              <a:t> və </a:t>
+            </a:r>
+            <a:r>
+              <a:rPr lang="az-Latn-AZ" altLang="en-US" sz="1300" b="1">
+                <a:latin typeface="Arial" panose="020B0604020202020204" pitchFamily="34" charset="0"/>
+              </a:rPr>
+              <a:t>CSS</a:t>
+            </a:r>
+            <a:r>
+              <a:rPr lang="az-Latn-AZ" altLang="en-US" sz="1300">
+                <a:latin typeface="Arial" panose="020B0604020202020204" pitchFamily="34" charset="0"/>
+              </a:rPr>
+              <a:t> fayllarını  `</a:t>
+            </a:r>
+            <a:r>
+              <a:rPr lang="az-Latn-AZ" altLang="en-US" sz="1300" b="1">
+                <a:latin typeface="Arial" panose="020B0604020202020204" pitchFamily="34" charset="0"/>
+              </a:rPr>
+              <a:t>public\backend\assets\js</a:t>
+            </a:r>
+            <a:r>
+              <a:rPr lang="az-Latn-AZ" altLang="en-US" sz="1300">
+                <a:latin typeface="Arial" panose="020B0604020202020204" pitchFamily="34" charset="0"/>
+              </a:rPr>
+              <a:t>`  və  `</a:t>
+            </a:r>
+            <a:r>
+              <a:rPr lang="az-Latn-AZ" altLang="en-US" sz="1300" b="1">
+                <a:latin typeface="Arial" panose="020B0604020202020204" pitchFamily="34" charset="0"/>
+              </a:rPr>
+              <a:t>public\backend\assets\css</a:t>
+            </a:r>
+            <a:r>
+              <a:rPr lang="az-Latn-AZ" altLang="en-US" sz="1300">
+                <a:latin typeface="Arial" panose="020B0604020202020204" pitchFamily="34" charset="0"/>
+              </a:rPr>
+              <a:t>` qovluğuna köçürürük. </a:t>
+            </a:r>
+            <a:endParaRPr kumimoji="0" lang="en-US" altLang="en-US" sz="1300" b="0" i="0" u="none" strike="noStrike" cap="none" normalizeH="0" baseline="0">
+              <a:ln>
+                <a:noFill/>
+              </a:ln>
+              <a:solidFill>
+                <a:schemeClr val="tx1"/>
+              </a:solidFill>
+              <a:effectLst/>
+              <a:latin typeface="Arial" panose="020B0604020202020204" pitchFamily="34" charset="0"/>
+            </a:endParaRPr>
+          </a:p>
+        </p:txBody>
+      </p:sp>
+      <p:pic>
+        <p:nvPicPr>
+          <p:cNvPr id="6" name="Picture 5">
+            <a:extLst>
+              <a:ext uri="{FF2B5EF4-FFF2-40B4-BE49-F238E27FC236}">
+                <a16:creationId xmlns:a16="http://schemas.microsoft.com/office/drawing/2014/main" id="{58BB6DF1-C032-EF57-0586-1EB2D99AE0C0}"/>
+              </a:ext>
+            </a:extLst>
+          </p:cNvPr>
+          <p:cNvPicPr>
+            <a:picLocks noChangeAspect="1"/>
+          </p:cNvPicPr>
+          <p:nvPr/>
+        </p:nvPicPr>
+        <p:blipFill>
+          <a:blip r:embed="rId2"/>
+          <a:stretch>
+            <a:fillRect/>
+          </a:stretch>
+        </p:blipFill>
+        <p:spPr>
+          <a:xfrm>
+            <a:off x="-2" y="638964"/>
+            <a:ext cx="12192000" cy="3508855"/>
+          </a:xfrm>
+          <a:prstGeom prst="rect">
+            <a:avLst/>
+          </a:prstGeom>
+          <a:ln w="38100" cap="sq">
+            <a:solidFill>
+              <a:srgbClr val="000000"/>
+            </a:solidFill>
+            <a:prstDash val="solid"/>
+            <a:miter lim="800000"/>
+          </a:ln>
+          <a:effectLst>
+            <a:outerShdw blurRad="50800" dist="38100" dir="2700000" algn="tl" rotWithShape="0">
+              <a:srgbClr val="000000">
+                <a:alpha val="43000"/>
+              </a:srgbClr>
+            </a:outerShdw>
+          </a:effectLst>
+        </p:spPr>
+      </p:pic>
+      <p:pic>
+        <p:nvPicPr>
+          <p:cNvPr id="10" name="Picture 9">
+            <a:extLst>
+              <a:ext uri="{FF2B5EF4-FFF2-40B4-BE49-F238E27FC236}">
+                <a16:creationId xmlns:a16="http://schemas.microsoft.com/office/drawing/2014/main" id="{7A62EB17-EAAE-2523-97DC-6C04E2B28F52}"/>
+              </a:ext>
+            </a:extLst>
+          </p:cNvPr>
+          <p:cNvPicPr>
+            <a:picLocks noChangeAspect="1"/>
+          </p:cNvPicPr>
+          <p:nvPr/>
+        </p:nvPicPr>
+        <p:blipFill>
+          <a:blip r:embed="rId3"/>
+          <a:stretch>
+            <a:fillRect/>
+          </a:stretch>
+        </p:blipFill>
+        <p:spPr>
+          <a:xfrm>
+            <a:off x="0" y="4570808"/>
+            <a:ext cx="12192000" cy="2287192"/>
+          </a:xfrm>
+          <a:prstGeom prst="rect">
+            <a:avLst/>
+          </a:prstGeom>
+          <a:ln w="38100" cap="sq">
+            <a:solidFill>
+              <a:srgbClr val="000000"/>
+            </a:solidFill>
+            <a:prstDash val="solid"/>
+            <a:miter lim="800000"/>
+          </a:ln>
+          <a:effectLst>
+            <a:outerShdw blurRad="50800" dist="38100" dir="2700000" algn="tl" rotWithShape="0">
+              <a:srgbClr val="000000">
+                <a:alpha val="43000"/>
+              </a:srgbClr>
+            </a:outerShdw>
+          </a:effectLst>
+        </p:spPr>
+      </p:pic>
+    </p:spTree>
+    <p:extLst>
+      <p:ext uri="{BB962C8B-B14F-4D97-AF65-F5344CB8AC3E}">
+        <p14:creationId xmlns:p14="http://schemas.microsoft.com/office/powerpoint/2010/main" val="2228751174"/>
+      </p:ext>
+    </p:extLst>
+  </p:cSld>
+  <p:clrMapOvr>
+    <a:masterClrMapping/>
+  </p:clrMapOvr>
+</p:sld>
+</file>
+
+<file path=ppt/slides/slide6.xml><?xml version="1.0" encoding="utf-8"?>
+<p:sld xmlns:a="http://schemas.openxmlformats.org/drawingml/2006/main" xmlns:r="http://schemas.openxmlformats.org/officeDocument/2006/relationships" xmlns:p="http://schemas.openxmlformats.org/presentationml/2006/main">
+  <p:cSld>
+    <p:spTree>
+      <p:nvGrpSpPr>
+        <p:cNvPr id="1" name="">
+          <a:extLst>
+            <a:ext uri="{FF2B5EF4-FFF2-40B4-BE49-F238E27FC236}">
+              <a16:creationId xmlns:a16="http://schemas.microsoft.com/office/drawing/2014/main" id="{FD0F0461-CA5E-BB26-9C56-D15BA0ED9B05}"/>
+            </a:ext>
+          </a:extLst>
+        </p:cNvPr>
+        <p:cNvGrpSpPr/>
+        <p:nvPr/>
+      </p:nvGrpSpPr>
+      <p:grpSpPr>
+        <a:xfrm>
+          <a:off x="0" y="0"/>
+          <a:ext cx="0" cy="0"/>
+          <a:chOff x="0" y="0"/>
+          <a:chExt cx="0" cy="0"/>
+        </a:xfrm>
+      </p:grpSpPr>
+      <p:sp>
+        <p:nvSpPr>
+          <p:cNvPr id="3" name="TextBox 2">
+            <a:extLst>
+              <a:ext uri="{FF2B5EF4-FFF2-40B4-BE49-F238E27FC236}">
+                <a16:creationId xmlns:a16="http://schemas.microsoft.com/office/drawing/2014/main" id="{6C276987-6AFE-D8B2-74EE-15FE0252EE47}"/>
+              </a:ext>
+            </a:extLst>
+          </p:cNvPr>
+          <p:cNvSpPr txBox="1"/>
+          <p:nvPr/>
+        </p:nvSpPr>
+        <p:spPr>
+          <a:xfrm>
+            <a:off x="217714" y="255046"/>
+            <a:ext cx="11756571" cy="355354"/>
+          </a:xfrm>
+          <a:prstGeom prst="rect">
+            <a:avLst/>
+          </a:prstGeom>
+          <a:noFill/>
+        </p:spPr>
+        <p:txBody>
+          <a:bodyPr wrap="square">
+            <a:spAutoFit/>
+          </a:bodyPr>
+          <a:lstStyle/>
+          <a:p>
+            <a:pPr>
+              <a:lnSpc>
+                <a:spcPct val="150000"/>
+              </a:lnSpc>
+              <a:buNone/>
+            </a:pPr>
+            <a:r>
+              <a:rPr lang="az-Latn-AZ" altLang="en-US" sz="1300">
+                <a:latin typeface="Arial" panose="020B0604020202020204" pitchFamily="34" charset="0"/>
+              </a:rPr>
+              <a:t>Həmin bootstrap icon fayllarını </a:t>
+            </a:r>
+            <a:r>
+              <a:rPr lang="az-Latn-AZ" altLang="en-US" sz="1300" b="1">
+                <a:latin typeface="Arial" panose="020B0604020202020204" pitchFamily="34" charset="0"/>
+              </a:rPr>
+              <a:t>link</a:t>
+            </a:r>
+            <a:r>
+              <a:rPr lang="az-Latn-AZ" altLang="en-US" sz="1300">
+                <a:latin typeface="Arial" panose="020B0604020202020204" pitchFamily="34" charset="0"/>
+              </a:rPr>
+              <a:t> və </a:t>
+            </a:r>
+            <a:r>
+              <a:rPr lang="az-Latn-AZ" altLang="en-US" sz="1300" b="1">
+                <a:latin typeface="Arial" panose="020B0604020202020204" pitchFamily="34" charset="0"/>
+              </a:rPr>
+              <a:t>script</a:t>
+            </a:r>
+            <a:r>
+              <a:rPr lang="az-Latn-AZ" altLang="en-US" sz="1300">
+                <a:latin typeface="Arial" panose="020B0604020202020204" pitchFamily="34" charset="0"/>
+              </a:rPr>
+              <a:t> tagləri ilə, `</a:t>
+            </a:r>
+            <a:r>
+              <a:rPr lang="en-US" altLang="en-US" sz="1300">
+                <a:latin typeface="Arial" panose="020B0604020202020204" pitchFamily="34" charset="0"/>
+              </a:rPr>
+              <a:t> </a:t>
+            </a:r>
+            <a:r>
+              <a:rPr lang="en-US" altLang="en-US" sz="1300" b="1">
+                <a:latin typeface="Arial" panose="020B0604020202020204" pitchFamily="34" charset="0"/>
+              </a:rPr>
+              <a:t>resources\views\admin\layouts\master.blade.php </a:t>
+            </a:r>
+            <a:r>
+              <a:rPr lang="az-Latn-AZ" altLang="en-US" sz="1300">
+                <a:latin typeface="Arial" panose="020B0604020202020204" pitchFamily="34" charset="0"/>
+              </a:rPr>
+              <a:t>` faylına əlavə edirik.</a:t>
+            </a:r>
+            <a:endParaRPr kumimoji="0" lang="en-US" altLang="en-US" sz="1300" b="0" i="0" u="none" strike="noStrike" cap="none" normalizeH="0" baseline="0">
+              <a:ln>
+                <a:noFill/>
+              </a:ln>
+              <a:solidFill>
+                <a:schemeClr val="tx1"/>
+              </a:solidFill>
+              <a:effectLst/>
+              <a:latin typeface="Arial" panose="020B0604020202020204" pitchFamily="34" charset="0"/>
+            </a:endParaRPr>
+          </a:p>
+        </p:txBody>
+      </p:sp>
+      <p:pic>
+        <p:nvPicPr>
+          <p:cNvPr id="6" name="Picture 5">
+            <a:extLst>
+              <a:ext uri="{FF2B5EF4-FFF2-40B4-BE49-F238E27FC236}">
+                <a16:creationId xmlns:a16="http://schemas.microsoft.com/office/drawing/2014/main" id="{3AD36678-E10B-3A17-5DD8-A3D84A520638}"/>
+              </a:ext>
+            </a:extLst>
+          </p:cNvPr>
+          <p:cNvPicPr>
+            <a:picLocks noChangeAspect="1"/>
+          </p:cNvPicPr>
+          <p:nvPr/>
+        </p:nvPicPr>
+        <p:blipFill>
+          <a:blip r:embed="rId2"/>
+          <a:stretch>
+            <a:fillRect/>
+          </a:stretch>
+        </p:blipFill>
+        <p:spPr>
+          <a:xfrm>
+            <a:off x="5998362" y="868218"/>
+            <a:ext cx="6193638" cy="5989782"/>
+          </a:xfrm>
+          <a:prstGeom prst="rect">
+            <a:avLst/>
+          </a:prstGeom>
+        </p:spPr>
+      </p:pic>
+    </p:spTree>
+    <p:extLst>
+      <p:ext uri="{BB962C8B-B14F-4D97-AF65-F5344CB8AC3E}">
+        <p14:creationId xmlns:p14="http://schemas.microsoft.com/office/powerpoint/2010/main" val="1803708434"/>
+      </p:ext>
+    </p:extLst>
+  </p:cSld>
+  <p:clrMapOvr>
+    <a:masterClrMapping/>
+  </p:clrMapOvr>
+</p:sld>
+</file>
+
+<file path=ppt/slides/slide7.xml><?xml version="1.0" encoding="utf-8"?>
+<p:sld xmlns:a="http://schemas.openxmlformats.org/drawingml/2006/main" xmlns:r="http://schemas.openxmlformats.org/officeDocument/2006/relationships" xmlns:p="http://schemas.openxmlformats.org/presentationml/2006/main">
+  <p:cSld>
+    <p:spTree>
+      <p:nvGrpSpPr>
+        <p:cNvPr id="1" name="">
+          <a:extLst>
+            <a:ext uri="{FF2B5EF4-FFF2-40B4-BE49-F238E27FC236}">
+              <a16:creationId xmlns:a16="http://schemas.microsoft.com/office/drawing/2014/main" id="{1A6EDB39-2977-43D1-DB6F-EDB19AF23E66}"/>
+            </a:ext>
+          </a:extLst>
+        </p:cNvPr>
+        <p:cNvGrpSpPr/>
+        <p:nvPr/>
+      </p:nvGrpSpPr>
+      <p:grpSpPr>
+        <a:xfrm>
+          <a:off x="0" y="0"/>
+          <a:ext cx="0" cy="0"/>
+          <a:chOff x="0" y="0"/>
+          <a:chExt cx="0" cy="0"/>
+        </a:xfrm>
+      </p:grpSpPr>
+      <p:sp>
+        <p:nvSpPr>
+          <p:cNvPr id="3" name="TextBox 2">
+            <a:extLst>
+              <a:ext uri="{FF2B5EF4-FFF2-40B4-BE49-F238E27FC236}">
+                <a16:creationId xmlns:a16="http://schemas.microsoft.com/office/drawing/2014/main" id="{6DB77334-150A-7AAE-C0CA-0B50D4680DAA}"/>
+              </a:ext>
+            </a:extLst>
+          </p:cNvPr>
+          <p:cNvSpPr txBox="1"/>
+          <p:nvPr/>
+        </p:nvSpPr>
+        <p:spPr>
+          <a:xfrm>
+            <a:off x="217714" y="255046"/>
+            <a:ext cx="11756571" cy="355354"/>
+          </a:xfrm>
+          <a:prstGeom prst="rect">
+            <a:avLst/>
+          </a:prstGeom>
+          <a:noFill/>
+        </p:spPr>
+        <p:txBody>
+          <a:bodyPr wrap="square">
+            <a:spAutoFit/>
+          </a:bodyPr>
+          <a:lstStyle/>
+          <a:p>
+            <a:pPr>
+              <a:lnSpc>
+                <a:spcPct val="150000"/>
+              </a:lnSpc>
+              <a:buNone/>
+            </a:pPr>
+            <a:r>
+              <a:rPr kumimoji="0" lang="az-Latn-AZ" altLang="en-US" sz="1300" b="0" i="0" u="none" strike="noStrike" cap="none" normalizeH="0" baseline="0">
+                <a:ln>
+                  <a:noFill/>
+                </a:ln>
+                <a:solidFill>
+                  <a:schemeClr val="tx1"/>
+                </a:solidFill>
+                <a:effectLst/>
+                <a:latin typeface="Arial" panose="020B0604020202020204" pitchFamily="34" charset="0"/>
+              </a:rPr>
+              <a:t>Bootstrap icon syatından BUTTON elementini götürürük və create.blade.php faylına yerləşdiririk.</a:t>
+            </a:r>
+            <a:endParaRPr kumimoji="0" lang="en-US" altLang="en-US" sz="1300" b="0" i="0" u="none" strike="noStrike" cap="none" normalizeH="0" baseline="0">
+              <a:ln>
+                <a:noFill/>
+              </a:ln>
+              <a:solidFill>
+                <a:schemeClr val="tx1"/>
+              </a:solidFill>
+              <a:effectLst/>
+              <a:latin typeface="Arial" panose="020B0604020202020204" pitchFamily="34" charset="0"/>
+            </a:endParaRPr>
+          </a:p>
+        </p:txBody>
+      </p:sp>
+      <p:pic>
+        <p:nvPicPr>
+          <p:cNvPr id="4" name="Picture 3">
+            <a:extLst>
+              <a:ext uri="{FF2B5EF4-FFF2-40B4-BE49-F238E27FC236}">
+                <a16:creationId xmlns:a16="http://schemas.microsoft.com/office/drawing/2014/main" id="{917B6178-4D54-2154-8BA5-F6AD9EEA0117}"/>
+              </a:ext>
+            </a:extLst>
+          </p:cNvPr>
+          <p:cNvPicPr>
+            <a:picLocks noChangeAspect="1"/>
+          </p:cNvPicPr>
+          <p:nvPr/>
+        </p:nvPicPr>
+        <p:blipFill>
+          <a:blip r:embed="rId2"/>
+          <a:stretch>
+            <a:fillRect/>
+          </a:stretch>
+        </p:blipFill>
+        <p:spPr>
+          <a:xfrm>
+            <a:off x="3556000" y="927700"/>
+            <a:ext cx="8636000" cy="5930300"/>
+          </a:xfrm>
+          <a:prstGeom prst="rect">
+            <a:avLst/>
+          </a:prstGeom>
+        </p:spPr>
+      </p:pic>
+    </p:spTree>
+    <p:extLst>
+      <p:ext uri="{BB962C8B-B14F-4D97-AF65-F5344CB8AC3E}">
+        <p14:creationId xmlns:p14="http://schemas.microsoft.com/office/powerpoint/2010/main" val="560439698"/>
+      </p:ext>
+    </p:extLst>
+  </p:cSld>
+  <p:clrMapOvr>
+    <a:masterClrMapping/>
+  </p:clrMapOvr>
+</p:sld>
+</file>
+
+<file path=ppt/slides/slide8.xml><?xml version="1.0" encoding="utf-8"?>
 <p:sld xmlns:a="http://schemas.openxmlformats.org/drawingml/2006/main" xmlns:r="http://schemas.openxmlformats.org/officeDocument/2006/relationships" xmlns:p="http://schemas.openxmlformats.org/presentationml/2006/main">
   <p:cSld>
     <p:spTree>
@@ -3455,21 +4884,68 @@
               <a:buNone/>
             </a:pPr>
             <a:r>
-              <a:rPr kumimoji="0" lang="en-US" altLang="en-US" sz="1300" b="0" i="0" u="none" strike="noStrike" cap="none" normalizeH="0" baseline="0">
-                <a:ln>
-                  <a:noFill/>
-                </a:ln>
-                <a:solidFill>
-                  <a:schemeClr val="tx1"/>
-                </a:solidFill>
-                <a:effectLst/>
-                <a:latin typeface="Arial" panose="020B0604020202020204" pitchFamily="34" charset="0"/>
-              </a:rPr>
-              <a:t>.</a:t>
-            </a:r>
-          </a:p>
-        </p:txBody>
-      </p:sp>
+              <a:rPr lang="az-Latn-AZ" altLang="en-US" sz="1300">
+                <a:latin typeface="Arial" panose="020B0604020202020204" pitchFamily="34" charset="0"/>
+              </a:rPr>
+              <a:t>Nəticə.</a:t>
+            </a:r>
+            <a:endParaRPr kumimoji="0" lang="en-US" altLang="en-US" sz="1300" b="0" i="0" u="none" strike="noStrike" cap="none" normalizeH="0" baseline="0">
+              <a:ln>
+                <a:noFill/>
+              </a:ln>
+              <a:solidFill>
+                <a:schemeClr val="tx1"/>
+              </a:solidFill>
+              <a:effectLst/>
+              <a:latin typeface="Arial" panose="020B0604020202020204" pitchFamily="34" charset="0"/>
+            </a:endParaRPr>
+          </a:p>
+        </p:txBody>
+      </p:sp>
+      <p:pic>
+        <p:nvPicPr>
+          <p:cNvPr id="4" name="Picture 3">
+            <a:extLst>
+              <a:ext uri="{FF2B5EF4-FFF2-40B4-BE49-F238E27FC236}">
+                <a16:creationId xmlns:a16="http://schemas.microsoft.com/office/drawing/2014/main" id="{B26932B8-FB30-F0C1-57D8-E86C34AE3F2D}"/>
+              </a:ext>
+            </a:extLst>
+          </p:cNvPr>
+          <p:cNvPicPr>
+            <a:picLocks noChangeAspect="1"/>
+          </p:cNvPicPr>
+          <p:nvPr/>
+        </p:nvPicPr>
+        <p:blipFill>
+          <a:blip r:embed="rId2"/>
+          <a:stretch>
+            <a:fillRect/>
+          </a:stretch>
+        </p:blipFill>
+        <p:spPr>
+          <a:xfrm>
+            <a:off x="0" y="2181965"/>
+            <a:ext cx="12192000" cy="4676035"/>
+          </a:xfrm>
+          <a:prstGeom prst="rect">
+            <a:avLst/>
+          </a:prstGeom>
+          <a:ln w="38100" cap="sq">
+            <a:solidFill>
+              <a:srgbClr val="000000"/>
+            </a:solidFill>
+            <a:prstDash val="solid"/>
+            <a:miter lim="800000"/>
+          </a:ln>
+          <a:effectLst>
+            <a:outerShdw blurRad="50800" dist="38100" dir="2700000" algn="tl" rotWithShape="0">
+              <a:srgbClr val="000000">
+                <a:alpha val="43000"/>
+              </a:srgbClr>
+            </a:outerShdw>
+          </a:effectLst>
+        </p:spPr>
+      </p:pic>
     </p:spTree>
     <p:extLst>
       <p:ext uri="{BB962C8B-B14F-4D97-AF65-F5344CB8AC3E}">
@@ -3483,7 +4959,7 @@
 </p:sld>
 </file>
 
-<file path=ppt/slides/slide3.xml><?xml version="1.0" encoding="utf-8"?>
+<file path=ppt/slides/slide9.xml><?xml version="1.0" encoding="utf-8"?>
 <p:sld xmlns:a="http://schemas.openxmlformats.org/drawingml/2006/main" xmlns:r="http://schemas.openxmlformats.org/officeDocument/2006/relationships" xmlns:p="http://schemas.openxmlformats.org/presentationml/2006/main">
   <p:cSld>
     <p:spTree>

</xml_diff>